<commit_message>
chore: add verification script and test run logs
</commit_message>
<xml_diff>
--- a/dpi-ls-validation.pptx
+++ b/dpi-ls-validation.pptx
@@ -308,7 +308,7 @@
           <a:p>
             <a:fld id="{5BCAD085-E8A6-8845-BD4E-CB4CCA059FC4}" type="datetimeFigureOut">
               <a:rPr lang="en-US" smtClean="0"/>
-              <a:t>7/2/2026</a:t>
+              <a:t>7/3/2026</a:t>
             </a:fld>
             <a:endParaRPr lang="en-US"/>
           </a:p>
@@ -476,7 +476,7 @@
           <a:p>
             <a:fld id="{5BCAD085-E8A6-8845-BD4E-CB4CCA059FC4}" type="datetimeFigureOut">
               <a:rPr lang="en-US" smtClean="0"/>
-              <a:t>7/2/2026</a:t>
+              <a:t>7/3/2026</a:t>
             </a:fld>
             <a:endParaRPr lang="en-US"/>
           </a:p>
@@ -654,7 +654,7 @@
           <a:p>
             <a:fld id="{5BCAD085-E8A6-8845-BD4E-CB4CCA059FC4}" type="datetimeFigureOut">
               <a:rPr lang="en-US" smtClean="0"/>
-              <a:t>7/2/2026</a:t>
+              <a:t>7/3/2026</a:t>
             </a:fld>
             <a:endParaRPr lang="en-US"/>
           </a:p>
@@ -822,7 +822,7 @@
           <a:p>
             <a:fld id="{5BCAD085-E8A6-8845-BD4E-CB4CCA059FC4}" type="datetimeFigureOut">
               <a:rPr lang="en-US" smtClean="0"/>
-              <a:t>7/2/2026</a:t>
+              <a:t>7/3/2026</a:t>
             </a:fld>
             <a:endParaRPr lang="en-US"/>
           </a:p>
@@ -1067,7 +1067,7 @@
           <a:p>
             <a:fld id="{5BCAD085-E8A6-8845-BD4E-CB4CCA059FC4}" type="datetimeFigureOut">
               <a:rPr lang="en-US" smtClean="0"/>
-              <a:t>7/2/2026</a:t>
+              <a:t>7/3/2026</a:t>
             </a:fld>
             <a:endParaRPr lang="en-US"/>
           </a:p>
@@ -1352,7 +1352,7 @@
           <a:p>
             <a:fld id="{5BCAD085-E8A6-8845-BD4E-CB4CCA059FC4}" type="datetimeFigureOut">
               <a:rPr lang="en-US" smtClean="0"/>
-              <a:t>7/2/2026</a:t>
+              <a:t>7/3/2026</a:t>
             </a:fld>
             <a:endParaRPr lang="en-US"/>
           </a:p>
@@ -1771,7 +1771,7 @@
           <a:p>
             <a:fld id="{5BCAD085-E8A6-8845-BD4E-CB4CCA059FC4}" type="datetimeFigureOut">
               <a:rPr lang="en-US" smtClean="0"/>
-              <a:t>7/2/2026</a:t>
+              <a:t>7/3/2026</a:t>
             </a:fld>
             <a:endParaRPr lang="en-US"/>
           </a:p>
@@ -1888,7 +1888,7 @@
           <a:p>
             <a:fld id="{5BCAD085-E8A6-8845-BD4E-CB4CCA059FC4}" type="datetimeFigureOut">
               <a:rPr lang="en-US" smtClean="0"/>
-              <a:t>7/2/2026</a:t>
+              <a:t>7/3/2026</a:t>
             </a:fld>
             <a:endParaRPr lang="en-US"/>
           </a:p>
@@ -1983,7 +1983,7 @@
           <a:p>
             <a:fld id="{5BCAD085-E8A6-8845-BD4E-CB4CCA059FC4}" type="datetimeFigureOut">
               <a:rPr lang="en-US" smtClean="0"/>
-              <a:t>7/2/2026</a:t>
+              <a:t>7/3/2026</a:t>
             </a:fld>
             <a:endParaRPr lang="en-US"/>
           </a:p>
@@ -2258,7 +2258,7 @@
           <a:p>
             <a:fld id="{5BCAD085-E8A6-8845-BD4E-CB4CCA059FC4}" type="datetimeFigureOut">
               <a:rPr lang="en-US" smtClean="0"/>
-              <a:t>7/2/2026</a:t>
+              <a:t>7/3/2026</a:t>
             </a:fld>
             <a:endParaRPr lang="en-US"/>
           </a:p>
@@ -2510,7 +2510,7 @@
           <a:p>
             <a:fld id="{5BCAD085-E8A6-8845-BD4E-CB4CCA059FC4}" type="datetimeFigureOut">
               <a:rPr lang="en-US" smtClean="0"/>
-              <a:t>7/2/2026</a:t>
+              <a:t>7/3/2026</a:t>
             </a:fld>
             <a:endParaRPr lang="en-US"/>
           </a:p>
@@ -2721,7 +2721,7 @@
           <a:p>
             <a:fld id="{5BCAD085-E8A6-8845-BD4E-CB4CCA059FC4}" type="datetimeFigureOut">
               <a:rPr lang="en-US" smtClean="0"/>
-              <a:t>7/2/2026</a:t>
+              <a:t>7/3/2026</a:t>
             </a:fld>
             <a:endParaRPr lang="en-US"/>
           </a:p>
@@ -3209,7 +3209,7 @@
         <p:spPr>
           <a:xfrm>
             <a:off x="1097280" y="4114800"/>
-            <a:ext cx="10058400" cy="1828800"/>
+            <a:ext cx="10058400" cy="1218282"/>
           </a:xfrm>
           <a:prstGeom prst="rect">
             <a:avLst/>
@@ -3249,24 +3249,35 @@
             </a:pPr>
             <a:r>
               <a:rPr dirty="0"/>
-              <a:t>Presented to: Wipro, Deloitte, JP Morgan, EY, PwC, Infosys &amp; Regeneron</a:t>
-            </a:r>
-          </a:p>
-          <a:p>
-            <a:pPr>
-              <a:spcBef>
-                <a:spcPts val="500"/>
-              </a:spcBef>
-              <a:defRPr sz="1200">
-                <a:solidFill>
-                  <a:srgbClr val="FFFFFF"/>
-                </a:solidFill>
-                <a:latin typeface="Arial"/>
-              </a:defRPr>
-            </a:pPr>
+              <a:t>Presented to:</a:t>
+            </a:r>
+            <a:r>
+              <a:rPr lang="en-IN" dirty="0"/>
+              <a:t> </a:t>
+            </a:r>
             <a:r>
               <a:rPr dirty="0"/>
-              <a:t>Executive Briefing: CEO, Ranga (CEO), Phani (Lead)</a:t>
+              <a:t>Executive Briefing: CEO, Ranga (</a:t>
+            </a:r>
+            <a:r>
+              <a:rPr lang="en-IN" dirty="0"/>
+              <a:t> group managers </a:t>
+            </a:r>
+            <a:r>
+              <a:rPr dirty="0"/>
+              <a:t>), Phani</a:t>
+            </a:r>
+            <a:r>
+              <a:rPr lang="en-IN" dirty="0" err="1"/>
+              <a:t>ndra</a:t>
+            </a:r>
+            <a:r>
+              <a:rPr lang="en-IN" dirty="0"/>
+              <a:t> </a:t>
+            </a:r>
+            <a:r>
+              <a:rPr dirty="0"/>
+              <a:t>(Lead)</a:t>
             </a:r>
           </a:p>
           <a:p>
@@ -5416,7 +5427,7 @@
           </a:bodyPr>
           <a:lstStyle/>
           <a:p>
-            <a:endParaRPr/>
+            <a:endParaRPr dirty="0"/>
           </a:p>
           <a:p>
             <a:pPr>
@@ -5430,7 +5441,16 @@
               </a:defRPr>
             </a:pPr>
             <a:r>
-              <a:t>✅ DeepEval integrated</a:t>
+              <a:rPr dirty="0"/>
+              <a:t>✅ </a:t>
+            </a:r>
+            <a:r>
+              <a:rPr dirty="0" err="1"/>
+              <a:t>DeepEval</a:t>
+            </a:r>
+            <a:r>
+              <a:rPr dirty="0"/>
+              <a:t> integrated</a:t>
             </a:r>
           </a:p>
           <a:p>
@@ -5445,6 +5465,7 @@
               </a:defRPr>
             </a:pPr>
             <a:r>
+              <a:rPr dirty="0"/>
               <a:t>✅ Jaeger integrated</a:t>
             </a:r>
           </a:p>
@@ -5460,6 +5481,7 @@
               </a:defRPr>
             </a:pPr>
             <a:r>
+              <a:rPr dirty="0"/>
               <a:t>✅ Zipkin integrated</a:t>
             </a:r>
           </a:p>
@@ -5475,7 +5497,16 @@
               </a:defRPr>
             </a:pPr>
             <a:r>
-              <a:t>✅ OpenTelemetry implemented</a:t>
+              <a:rPr dirty="0"/>
+              <a:t>✅ </a:t>
+            </a:r>
+            <a:r>
+              <a:rPr dirty="0" err="1"/>
+              <a:t>OpenTelemetry</a:t>
+            </a:r>
+            <a:r>
+              <a:rPr dirty="0"/>
+              <a:t> implemented</a:t>
             </a:r>
           </a:p>
           <a:p>
@@ -5490,6 +5521,7 @@
               </a:defRPr>
             </a:pPr>
             <a:r>
+              <a:rPr dirty="0"/>
               <a:t>✅ Validation Resources Dashboard</a:t>
             </a:r>
           </a:p>
@@ -5505,6 +5537,7 @@
               </a:defRPr>
             </a:pPr>
             <a:r>
+              <a:rPr dirty="0"/>
               <a:t>✅ Live Runtime Metrics</a:t>
             </a:r>
           </a:p>
@@ -5520,7 +5553,16 @@
               </a:defRPr>
             </a:pPr>
             <a:r>
-              <a:t>✅ FastAPI Backend</a:t>
+              <a:rPr dirty="0"/>
+              <a:t>✅ </a:t>
+            </a:r>
+            <a:r>
+              <a:rPr dirty="0" err="1"/>
+              <a:t>FastAPI</a:t>
+            </a:r>
+            <a:r>
+              <a:rPr dirty="0"/>
+              <a:t> Backend</a:t>
             </a:r>
           </a:p>
           <a:p>
@@ -5535,6 +5577,7 @@
               </a:defRPr>
             </a:pPr>
             <a:r>
+              <a:rPr dirty="0"/>
               <a:t>✅ SQLite Integration</a:t>
             </a:r>
           </a:p>
@@ -5550,12 +5593,16 @@
               </a:defRPr>
             </a:pPr>
             <a:r>
+              <a:rPr dirty="0"/>
               <a:t>✅ Development Testing Completed</a:t>
             </a:r>
           </a:p>
           <a:p>
-            <a:br/>
-            <a:r>
+            <a:br>
+              <a:rPr dirty="0"/>
+            </a:br>
+            <a:r>
+              <a:rPr dirty="0"/>
               <a:t>Next Steps:</a:t>
             </a:r>
           </a:p>
@@ -5571,6 +5618,7 @@
               </a:defRPr>
             </a:pPr>
             <a:r>
+              <a:rPr dirty="0"/>
               <a:t>• Regeneron AWS validation</a:t>
             </a:r>
           </a:p>
@@ -5586,6 +5634,7 @@
               </a:defRPr>
             </a:pPr>
             <a:r>
+              <a:rPr dirty="0"/>
               <a:t>• Regeneron RDS</a:t>
             </a:r>
           </a:p>
@@ -5601,6 +5650,7 @@
               </a:defRPr>
             </a:pPr>
             <a:r>
+              <a:rPr dirty="0"/>
               <a:t>• Approved Benchmark Dataset</a:t>
             </a:r>
           </a:p>
@@ -5616,6 +5666,7 @@
               </a:defRPr>
             </a:pPr>
             <a:r>
+              <a:rPr dirty="0"/>
               <a:t>• Production Recall Measurement</a:t>
             </a:r>
           </a:p>
@@ -5631,6 +5682,7 @@
               </a:defRPr>
             </a:pPr>
             <a:r>
+              <a:rPr dirty="0"/>
               <a:t>• M6 Validation</a:t>
             </a:r>
           </a:p>

</xml_diff>

<commit_message>
chore: update verification script and save latest metrics
</commit_message>
<xml_diff>
--- a/dpi-ls-validation.pptx
+++ b/dpi-ls-validation.pptx
@@ -308,7 +308,7 @@
           <a:p>
             <a:fld id="{5BCAD085-E8A6-8845-BD4E-CB4CCA059FC4}" type="datetimeFigureOut">
               <a:rPr lang="en-US" smtClean="0"/>
-              <a:t>7/3/2026</a:t>
+              <a:t>7/6/2026</a:t>
             </a:fld>
             <a:endParaRPr lang="en-US"/>
           </a:p>
@@ -476,7 +476,7 @@
           <a:p>
             <a:fld id="{5BCAD085-E8A6-8845-BD4E-CB4CCA059FC4}" type="datetimeFigureOut">
               <a:rPr lang="en-US" smtClean="0"/>
-              <a:t>7/3/2026</a:t>
+              <a:t>7/6/2026</a:t>
             </a:fld>
             <a:endParaRPr lang="en-US"/>
           </a:p>
@@ -654,7 +654,7 @@
           <a:p>
             <a:fld id="{5BCAD085-E8A6-8845-BD4E-CB4CCA059FC4}" type="datetimeFigureOut">
               <a:rPr lang="en-US" smtClean="0"/>
-              <a:t>7/3/2026</a:t>
+              <a:t>7/6/2026</a:t>
             </a:fld>
             <a:endParaRPr lang="en-US"/>
           </a:p>
@@ -822,7 +822,7 @@
           <a:p>
             <a:fld id="{5BCAD085-E8A6-8845-BD4E-CB4CCA059FC4}" type="datetimeFigureOut">
               <a:rPr lang="en-US" smtClean="0"/>
-              <a:t>7/3/2026</a:t>
+              <a:t>7/6/2026</a:t>
             </a:fld>
             <a:endParaRPr lang="en-US"/>
           </a:p>
@@ -1067,7 +1067,7 @@
           <a:p>
             <a:fld id="{5BCAD085-E8A6-8845-BD4E-CB4CCA059FC4}" type="datetimeFigureOut">
               <a:rPr lang="en-US" smtClean="0"/>
-              <a:t>7/3/2026</a:t>
+              <a:t>7/6/2026</a:t>
             </a:fld>
             <a:endParaRPr lang="en-US"/>
           </a:p>
@@ -1352,7 +1352,7 @@
           <a:p>
             <a:fld id="{5BCAD085-E8A6-8845-BD4E-CB4CCA059FC4}" type="datetimeFigureOut">
               <a:rPr lang="en-US" smtClean="0"/>
-              <a:t>7/3/2026</a:t>
+              <a:t>7/6/2026</a:t>
             </a:fld>
             <a:endParaRPr lang="en-US"/>
           </a:p>
@@ -1771,7 +1771,7 @@
           <a:p>
             <a:fld id="{5BCAD085-E8A6-8845-BD4E-CB4CCA059FC4}" type="datetimeFigureOut">
               <a:rPr lang="en-US" smtClean="0"/>
-              <a:t>7/3/2026</a:t>
+              <a:t>7/6/2026</a:t>
             </a:fld>
             <a:endParaRPr lang="en-US"/>
           </a:p>
@@ -1888,7 +1888,7 @@
           <a:p>
             <a:fld id="{5BCAD085-E8A6-8845-BD4E-CB4CCA059FC4}" type="datetimeFigureOut">
               <a:rPr lang="en-US" smtClean="0"/>
-              <a:t>7/3/2026</a:t>
+              <a:t>7/6/2026</a:t>
             </a:fld>
             <a:endParaRPr lang="en-US"/>
           </a:p>
@@ -1983,7 +1983,7 @@
           <a:p>
             <a:fld id="{5BCAD085-E8A6-8845-BD4E-CB4CCA059FC4}" type="datetimeFigureOut">
               <a:rPr lang="en-US" smtClean="0"/>
-              <a:t>7/3/2026</a:t>
+              <a:t>7/6/2026</a:t>
             </a:fld>
             <a:endParaRPr lang="en-US"/>
           </a:p>
@@ -2258,7 +2258,7 @@
           <a:p>
             <a:fld id="{5BCAD085-E8A6-8845-BD4E-CB4CCA059FC4}" type="datetimeFigureOut">
               <a:rPr lang="en-US" smtClean="0"/>
-              <a:t>7/3/2026</a:t>
+              <a:t>7/6/2026</a:t>
             </a:fld>
             <a:endParaRPr lang="en-US"/>
           </a:p>
@@ -2510,7 +2510,7 @@
           <a:p>
             <a:fld id="{5BCAD085-E8A6-8845-BD4E-CB4CCA059FC4}" type="datetimeFigureOut">
               <a:rPr lang="en-US" smtClean="0"/>
-              <a:t>7/3/2026</a:t>
+              <a:t>7/6/2026</a:t>
             </a:fld>
             <a:endParaRPr lang="en-US"/>
           </a:p>
@@ -2721,7 +2721,7 @@
           <a:p>
             <a:fld id="{5BCAD085-E8A6-8845-BD4E-CB4CCA059FC4}" type="datetimeFigureOut">
               <a:rPr lang="en-US" smtClean="0"/>
-              <a:t>7/3/2026</a:t>
+              <a:t>7/6/2026</a:t>
             </a:fld>
             <a:endParaRPr lang="en-US"/>
           </a:p>
@@ -3273,11 +3273,19 @@
             </a:r>
             <a:r>
               <a:rPr lang="en-IN" dirty="0"/>
-              <a:t> </a:t>
+              <a:t>  Sir </a:t>
             </a:r>
             <a:r>
               <a:rPr dirty="0"/>
-              <a:t>(Lead)</a:t>
+              <a:t>(</a:t>
+            </a:r>
+            <a:r>
+              <a:rPr lang="en-IN" dirty="0"/>
+              <a:t> Team </a:t>
+            </a:r>
+            <a:r>
+              <a:rPr dirty="0"/>
+              <a:t>Lead)</a:t>
             </a:r>
           </a:p>
           <a:p>
@@ -5413,7 +5421,7 @@
         </p:nvSpPr>
         <p:spPr>
           <a:xfrm>
-            <a:off x="731520" y="1371600"/>
+            <a:off x="1087120" y="1371600"/>
             <a:ext cx="10698480" cy="4754880"/>
           </a:xfrm>
           <a:prstGeom prst="rect">

</xml_diff>